<commit_message>
docs: give each SLO formula its own line and add prefill throughput
Measured prefill throughput joins the engine inputs. The control-law formulas no longer share a line, so the TTFT prediction and the KV-byte identity stay readable.

Co-authored-by: 69515164-rgb <69515164-rgb@users.noreply.github.com>
</commit_message>
<xml_diff>
--- a/docs/token-slo-engine.pptx
+++ b/docs/token-slo-engine.pptx
@@ -4099,7 +4099,7 @@
                 <a:ea typeface="Microsoft YaHei"/>
                 <a:cs typeface="Microsoft YaHei"/>
               </a:rPr>
-              <a:t>激活显存余量</a:t>
+              <a:t>prefill 实测吞吐</a:t>
             </a:r>
           </a:p>
         </p:txBody>
@@ -4542,7 +4542,7 @@
                 <a:ea typeface="Microsoft YaHei"/>
                 <a:cs typeface="Microsoft YaHei"/>
               </a:rPr>
-              <a:t>下游只读</a:t>
+              <a:t>资源与下游</a:t>
             </a:r>
           </a:p>
         </p:txBody>
@@ -4556,7 +4556,7 @@
         <p:spPr>
           <a:xfrm>
             <a:off x="402336" y="3980688"/>
-            <a:ext cx="2688336" cy="292608"/>
+            <a:ext cx="2688336" cy="221487"/>
           </a:xfrm>
           <a:prstGeom prst="rect">
             <a:avLst/>
@@ -4603,7 +4603,7 @@
                 <a:ea typeface="Microsoft YaHei"/>
                 <a:cs typeface="Microsoft YaHei"/>
               </a:rPr>
-              <a:t>KV 有效带宽与在途条数</a:t>
+              <a:t>激活显存余量</a:t>
             </a:r>
           </a:p>
         </p:txBody>
@@ -4616,8 +4616,8 @@
         </p:nvSpPr>
         <p:spPr>
           <a:xfrm>
-            <a:off x="402336" y="4328160"/>
-            <a:ext cx="2688336" cy="292608"/>
+            <a:off x="402336" y="4257040"/>
+            <a:ext cx="2688336" cy="221487"/>
           </a:xfrm>
           <a:prstGeom prst="rect">
             <a:avLst/>
@@ -4664,6 +4664,67 @@
                 <a:ea typeface="Microsoft YaHei"/>
                 <a:cs typeface="Microsoft YaHei"/>
               </a:rPr>
+              <a:t>KV 有效带宽与在途条数</a:t>
+            </a:r>
+          </a:p>
+        </p:txBody>
+      </p:sp>
+      <p:sp>
+        <p:nvSpPr>
+          <p:cNvPr id="24" name="Rectangle 23"/>
+          <p:cNvSpPr/>
+          <p:nvPr/>
+        </p:nvSpPr>
+        <p:spPr>
+          <a:xfrm>
+            <a:off x="402336" y="4533392"/>
+            <a:ext cx="2688336" cy="221487"/>
+          </a:xfrm>
+          <a:prstGeom prst="rect">
+            <a:avLst/>
+          </a:prstGeom>
+          <a:solidFill>
+            <a:srgbClr val="ECF0F4"/>
+          </a:solidFill>
+          <a:ln>
+            <a:noFill/>
+          </a:ln>
+        </p:spPr>
+        <p:style>
+          <a:lnRef idx="1">
+            <a:schemeClr val="accent1"/>
+          </a:lnRef>
+          <a:fillRef idx="3">
+            <a:schemeClr val="accent1"/>
+          </a:fillRef>
+          <a:effectRef idx="2">
+            <a:schemeClr val="accent1"/>
+          </a:effectRef>
+          <a:fontRef idx="minor">
+            <a:schemeClr val="lt1"/>
+          </a:fontRef>
+        </p:style>
+        <p:txBody>
+          <a:bodyPr rtlCol="0" anchor="ctr" wrap="square" lIns="54864" rIns="54864" tIns="18288" bIns="18288"/>
+          <a:lstStyle/>
+          <a:p>
+            <a:pPr algn="ctr">
+              <a:spcBef>
+                <a:spcPts val="0"/>
+              </a:spcBef>
+              <a:spcAft>
+                <a:spcPts val="0"/>
+              </a:spcAft>
+            </a:pPr>
+            <a:r>
+              <a:rPr sz="1200" b="1">
+                <a:solidFill>
+                  <a:srgbClr val="0E2A47"/>
+                </a:solidFill>
+                <a:latin typeface="Microsoft YaHei"/>
+                <a:ea typeface="Microsoft YaHei"/>
+                <a:cs typeface="Microsoft YaHei"/>
+              </a:rPr>
               <a:t>decode 空槽数</a:t>
             </a:r>
           </a:p>
@@ -4671,7 +4732,7 @@
       </p:sp>
       <p:sp>
         <p:nvSpPr>
-          <p:cNvPr id="24" name="Rectangle 23"/>
+          <p:cNvPr id="25" name="Rectangle 24"/>
           <p:cNvSpPr/>
           <p:nvPr/>
         </p:nvSpPr>
@@ -4714,7 +4775,7 @@
       </p:sp>
       <p:sp>
         <p:nvSpPr>
-          <p:cNvPr id="25" name="Rectangle 24"/>
+          <p:cNvPr id="26" name="Rectangle 25"/>
           <p:cNvSpPr/>
           <p:nvPr/>
         </p:nvSpPr>
@@ -4775,7 +4836,7 @@
       </p:sp>
       <p:sp>
         <p:nvSpPr>
-          <p:cNvPr id="26" name="Rectangle 25"/>
+          <p:cNvPr id="27" name="Rectangle 26"/>
           <p:cNvSpPr/>
           <p:nvPr/>
         </p:nvSpPr>
@@ -4820,7 +4881,7 @@
       </p:sp>
       <p:sp>
         <p:nvSpPr>
-          <p:cNvPr id="27" name="Rectangle 26"/>
+          <p:cNvPr id="28" name="Rectangle 27"/>
           <p:cNvSpPr/>
           <p:nvPr/>
         </p:nvSpPr>
@@ -4881,7 +4942,7 @@
       </p:sp>
       <p:sp>
         <p:nvSpPr>
-          <p:cNvPr id="28" name="TextBox 27"/>
+          <p:cNvPr id="29" name="TextBox 28"/>
           <p:cNvSpPr txBox="1"/>
           <p:nvPr/>
         </p:nvSpPr>
@@ -4923,7 +4984,7 @@
       </p:sp>
       <p:sp>
         <p:nvSpPr>
-          <p:cNvPr id="29" name="TextBox 28"/>
+          <p:cNvPr id="30" name="TextBox 29"/>
           <p:cNvSpPr txBox="1"/>
           <p:nvPr/>
         </p:nvSpPr>
@@ -4986,7 +5047,7 @@
       </p:sp>
       <p:sp>
         <p:nvSpPr>
-          <p:cNvPr id="30" name="Rectangle 29"/>
+          <p:cNvPr id="31" name="Rectangle 30"/>
           <p:cNvSpPr/>
           <p:nvPr/>
         </p:nvSpPr>
@@ -5031,7 +5092,7 @@
       </p:sp>
       <p:sp>
         <p:nvSpPr>
-          <p:cNvPr id="31" name="Rectangle 30"/>
+          <p:cNvPr id="32" name="Rectangle 31"/>
           <p:cNvSpPr/>
           <p:nvPr/>
         </p:nvSpPr>
@@ -5092,7 +5153,7 @@
       </p:sp>
       <p:sp>
         <p:nvSpPr>
-          <p:cNvPr id="32" name="TextBox 31"/>
+          <p:cNvPr id="33" name="TextBox 32"/>
           <p:cNvSpPr txBox="1"/>
           <p:nvPr/>
         </p:nvSpPr>
@@ -5134,7 +5195,7 @@
       </p:sp>
       <p:sp>
         <p:nvSpPr>
-          <p:cNvPr id="33" name="TextBox 32"/>
+          <p:cNvPr id="34" name="TextBox 33"/>
           <p:cNvSpPr txBox="1"/>
           <p:nvPr/>
         </p:nvSpPr>
@@ -5197,7 +5258,7 @@
       </p:sp>
       <p:sp>
         <p:nvSpPr>
-          <p:cNvPr id="34" name="Rectangle 33"/>
+          <p:cNvPr id="35" name="Rectangle 34"/>
           <p:cNvSpPr/>
           <p:nvPr/>
         </p:nvSpPr>
@@ -5242,7 +5303,7 @@
       </p:sp>
       <p:sp>
         <p:nvSpPr>
-          <p:cNvPr id="35" name="Rectangle 34"/>
+          <p:cNvPr id="36" name="Rectangle 35"/>
           <p:cNvSpPr/>
           <p:nvPr/>
         </p:nvSpPr>
@@ -5303,7 +5364,7 @@
       </p:sp>
       <p:sp>
         <p:nvSpPr>
-          <p:cNvPr id="36" name="TextBox 35"/>
+          <p:cNvPr id="37" name="TextBox 36"/>
           <p:cNvSpPr txBox="1"/>
           <p:nvPr/>
         </p:nvSpPr>
@@ -5345,7 +5406,7 @@
       </p:sp>
       <p:sp>
         <p:nvSpPr>
-          <p:cNvPr id="37" name="TextBox 36"/>
+          <p:cNvPr id="38" name="TextBox 37"/>
           <p:cNvSpPr txBox="1"/>
           <p:nvPr/>
         </p:nvSpPr>
@@ -5408,7 +5469,7 @@
       </p:sp>
       <p:sp>
         <p:nvSpPr>
-          <p:cNvPr id="38" name="Rectangle 37"/>
+          <p:cNvPr id="39" name="Rectangle 38"/>
           <p:cNvSpPr/>
           <p:nvPr/>
         </p:nvSpPr>
@@ -5453,7 +5514,7 @@
       </p:sp>
       <p:sp>
         <p:nvSpPr>
-          <p:cNvPr id="39" name="Rectangle 38"/>
+          <p:cNvPr id="40" name="Rectangle 39"/>
           <p:cNvSpPr/>
           <p:nvPr/>
         </p:nvSpPr>
@@ -5496,7 +5557,7 @@
       </p:sp>
       <p:sp>
         <p:nvSpPr>
-          <p:cNvPr id="40" name="TextBox 39"/>
+          <p:cNvPr id="41" name="TextBox 40"/>
           <p:cNvSpPr txBox="1"/>
           <p:nvPr/>
         </p:nvSpPr>
@@ -5538,7 +5599,7 @@
       </p:sp>
       <p:sp>
         <p:nvSpPr>
-          <p:cNvPr id="41" name="TextBox 40"/>
+          <p:cNvPr id="42" name="TextBox 41"/>
           <p:cNvSpPr txBox="1"/>
           <p:nvPr/>
         </p:nvSpPr>
@@ -5580,7 +5641,7 @@
       </p:sp>
       <p:sp>
         <p:nvSpPr>
-          <p:cNvPr id="42" name="Rectangle 41"/>
+          <p:cNvPr id="43" name="Rectangle 42"/>
           <p:cNvSpPr/>
           <p:nvPr/>
         </p:nvSpPr>
@@ -5641,7 +5702,7 @@
       </p:sp>
       <p:sp>
         <p:nvSpPr>
-          <p:cNvPr id="43" name="Rectangle 42"/>
+          <p:cNvPr id="44" name="Rectangle 43"/>
           <p:cNvSpPr/>
           <p:nvPr/>
         </p:nvSpPr>
@@ -5702,7 +5763,7 @@
       </p:sp>
       <p:sp>
         <p:nvSpPr>
-          <p:cNvPr id="44" name="Rectangle 43"/>
+          <p:cNvPr id="45" name="Rectangle 44"/>
           <p:cNvSpPr/>
           <p:nvPr/>
         </p:nvSpPr>
@@ -5763,7 +5824,7 @@
       </p:sp>
       <p:sp>
         <p:nvSpPr>
-          <p:cNvPr id="45" name="TextBox 44"/>
+          <p:cNvPr id="46" name="TextBox 45"/>
           <p:cNvSpPr txBox="1"/>
           <p:nvPr/>
         </p:nvSpPr>
@@ -5805,7 +5866,7 @@
       </p:sp>
       <p:sp>
         <p:nvSpPr>
-          <p:cNvPr id="46" name="Rectangle 45"/>
+          <p:cNvPr id="47" name="Rectangle 46"/>
           <p:cNvSpPr/>
           <p:nvPr/>
         </p:nvSpPr>
@@ -5850,7 +5911,7 @@
       </p:sp>
       <p:sp>
         <p:nvSpPr>
-          <p:cNvPr id="47" name="Rectangle 46"/>
+          <p:cNvPr id="48" name="Rectangle 47"/>
           <p:cNvSpPr/>
           <p:nvPr/>
         </p:nvSpPr>
@@ -5893,7 +5954,7 @@
       </p:sp>
       <p:sp>
         <p:nvSpPr>
-          <p:cNvPr id="48" name="TextBox 47"/>
+          <p:cNvPr id="49" name="TextBox 48"/>
           <p:cNvSpPr txBox="1"/>
           <p:nvPr/>
         </p:nvSpPr>
@@ -5935,7 +5996,7 @@
       </p:sp>
       <p:sp>
         <p:nvSpPr>
-          <p:cNvPr id="49" name="TextBox 48"/>
+          <p:cNvPr id="50" name="TextBox 49"/>
           <p:cNvSpPr txBox="1"/>
           <p:nvPr/>
         </p:nvSpPr>
@@ -5977,7 +6038,7 @@
       </p:sp>
       <p:sp>
         <p:nvSpPr>
-          <p:cNvPr id="50" name="Rectangle 49"/>
+          <p:cNvPr id="51" name="Rectangle 50"/>
           <p:cNvSpPr/>
           <p:nvPr/>
         </p:nvSpPr>
@@ -6038,7 +6099,7 @@
       </p:sp>
       <p:sp>
         <p:nvSpPr>
-          <p:cNvPr id="51" name="Rectangle 50"/>
+          <p:cNvPr id="52" name="Rectangle 51"/>
           <p:cNvSpPr/>
           <p:nvPr/>
         </p:nvSpPr>
@@ -6099,7 +6160,7 @@
       </p:sp>
       <p:sp>
         <p:nvSpPr>
-          <p:cNvPr id="52" name="Rectangle 51"/>
+          <p:cNvPr id="53" name="Rectangle 52"/>
           <p:cNvSpPr/>
           <p:nvPr/>
         </p:nvSpPr>
@@ -6160,7 +6221,7 @@
       </p:sp>
       <p:sp>
         <p:nvSpPr>
-          <p:cNvPr id="53" name="TextBox 52"/>
+          <p:cNvPr id="54" name="TextBox 53"/>
           <p:cNvSpPr txBox="1"/>
           <p:nvPr/>
         </p:nvSpPr>
@@ -6202,7 +6263,7 @@
       </p:sp>
       <p:sp>
         <p:nvSpPr>
-          <p:cNvPr id="54" name="Right Arrow 53"/>
+          <p:cNvPr id="55" name="Right Arrow 54"/>
           <p:cNvSpPr/>
           <p:nvPr/>
         </p:nvSpPr>
@@ -6245,7 +6306,7 @@
       </p:sp>
       <p:sp>
         <p:nvSpPr>
-          <p:cNvPr id="55" name="Right Arrow 54"/>
+          <p:cNvPr id="56" name="Right Arrow 55"/>
           <p:cNvSpPr/>
           <p:nvPr/>
         </p:nvSpPr>
@@ -6288,7 +6349,7 @@
       </p:sp>
       <p:sp>
         <p:nvSpPr>
-          <p:cNvPr id="56" name="Rectangle 55"/>
+          <p:cNvPr id="57" name="Rectangle 56"/>
           <p:cNvSpPr/>
           <p:nvPr/>
         </p:nvSpPr>
@@ -6349,7 +6410,7 @@
       </p:sp>
       <p:sp>
         <p:nvSpPr>
-          <p:cNvPr id="57" name="Rectangle 56"/>
+          <p:cNvPr id="58" name="Rectangle 57"/>
           <p:cNvSpPr/>
           <p:nvPr/>
         </p:nvSpPr>
@@ -6394,7 +6455,7 @@
       </p:sp>
       <p:sp>
         <p:nvSpPr>
-          <p:cNvPr id="58" name="Rectangle 57"/>
+          <p:cNvPr id="59" name="Rectangle 58"/>
           <p:cNvSpPr/>
           <p:nvPr/>
         </p:nvSpPr>
@@ -6437,7 +6498,7 @@
       </p:sp>
       <p:sp>
         <p:nvSpPr>
-          <p:cNvPr id="59" name="TextBox 58"/>
+          <p:cNvPr id="60" name="TextBox 59"/>
           <p:cNvSpPr txBox="1"/>
           <p:nvPr/>
         </p:nvSpPr>
@@ -6479,7 +6540,7 @@
       </p:sp>
       <p:sp>
         <p:nvSpPr>
-          <p:cNvPr id="60" name="TextBox 59"/>
+          <p:cNvPr id="61" name="TextBox 60"/>
           <p:cNvSpPr txBox="1"/>
           <p:nvPr/>
         </p:nvSpPr>
@@ -6521,7 +6582,7 @@
       </p:sp>
       <p:sp>
         <p:nvSpPr>
-          <p:cNvPr id="61" name="Rectangle 60"/>
+          <p:cNvPr id="62" name="Rectangle 61"/>
           <p:cNvSpPr/>
           <p:nvPr/>
         </p:nvSpPr>
@@ -6566,7 +6627,7 @@
       </p:sp>
       <p:sp>
         <p:nvSpPr>
-          <p:cNvPr id="62" name="Rectangle 61"/>
+          <p:cNvPr id="63" name="Rectangle 62"/>
           <p:cNvSpPr/>
           <p:nvPr/>
         </p:nvSpPr>
@@ -6609,7 +6670,7 @@
       </p:sp>
       <p:sp>
         <p:nvSpPr>
-          <p:cNvPr id="63" name="TextBox 62"/>
+          <p:cNvPr id="64" name="TextBox 63"/>
           <p:cNvSpPr txBox="1"/>
           <p:nvPr/>
         </p:nvSpPr>
@@ -6651,7 +6712,7 @@
       </p:sp>
       <p:sp>
         <p:nvSpPr>
-          <p:cNvPr id="64" name="TextBox 63"/>
+          <p:cNvPr id="65" name="TextBox 64"/>
           <p:cNvSpPr txBox="1"/>
           <p:nvPr/>
         </p:nvSpPr>
@@ -6693,7 +6754,7 @@
       </p:sp>
       <p:sp>
         <p:nvSpPr>
-          <p:cNvPr id="65" name="Rectangle 64"/>
+          <p:cNvPr id="66" name="Rectangle 65"/>
           <p:cNvSpPr/>
           <p:nvPr/>
         </p:nvSpPr>
@@ -6738,7 +6799,7 @@
       </p:sp>
       <p:sp>
         <p:nvSpPr>
-          <p:cNvPr id="66" name="Rectangle 65"/>
+          <p:cNvPr id="67" name="Rectangle 66"/>
           <p:cNvSpPr/>
           <p:nvPr/>
         </p:nvSpPr>
@@ -6781,7 +6842,7 @@
       </p:sp>
       <p:sp>
         <p:nvSpPr>
-          <p:cNvPr id="67" name="TextBox 66"/>
+          <p:cNvPr id="68" name="TextBox 67"/>
           <p:cNvSpPr txBox="1"/>
           <p:nvPr/>
         </p:nvSpPr>
@@ -6823,7 +6884,7 @@
       </p:sp>
       <p:sp>
         <p:nvSpPr>
-          <p:cNvPr id="68" name="TextBox 67"/>
+          <p:cNvPr id="69" name="TextBox 68"/>
           <p:cNvSpPr txBox="1"/>
           <p:nvPr/>
         </p:nvSpPr>
@@ -7101,8 +7162,8 @@
         </p:nvSpPr>
         <p:spPr>
           <a:xfrm>
-            <a:off x="292608" y="1133856"/>
-            <a:ext cx="11612880" cy="841248"/>
+            <a:off x="292608" y="1097280"/>
+            <a:ext cx="11612880" cy="1243584"/>
           </a:xfrm>
           <a:prstGeom prst="rect">
             <a:avLst/>
@@ -7151,7 +7212,49 @@
                 <a:ea typeface="Microsoft YaHei"/>
                 <a:cs typeface="Microsoft YaHei"/>
               </a:rPr>
-              <a:t>本批计算 = 下一批 token 数 / prefill 吞吐　　队列等待 = 队头已等 + 前面各批剩余时间</a:t>
+              <a:t>误差 = TTFT 目标 - 预测 TTFT</a:t>
+            </a:r>
+          </a:p>
+          <a:p>
+            <a:pPr algn="l">
+              <a:spcBef>
+                <a:spcPts val="0"/>
+              </a:spcBef>
+              <a:spcAft>
+                <a:spcPts val="0"/>
+              </a:spcAft>
+            </a:pPr>
+            <a:r>
+              <a:rPr sz="1300" b="0">
+                <a:solidFill>
+                  <a:srgbClr val="1C242E"/>
+                </a:solidFill>
+                <a:latin typeface="Microsoft YaHei"/>
+                <a:ea typeface="Microsoft YaHei"/>
+                <a:cs typeface="Microsoft YaHei"/>
+              </a:rPr>
+              <a:t>本批计算 = 下一批 token 数 / prefill 吞吐</a:t>
+            </a:r>
+          </a:p>
+          <a:p>
+            <a:pPr algn="l">
+              <a:spcBef>
+                <a:spcPts val="0"/>
+              </a:spcBef>
+              <a:spcAft>
+                <a:spcPts val="0"/>
+              </a:spcAft>
+            </a:pPr>
+            <a:r>
+              <a:rPr sz="1300" b="0">
+                <a:solidFill>
+                  <a:srgbClr val="1C242E"/>
+                </a:solidFill>
+                <a:latin typeface="Microsoft YaHei"/>
+                <a:ea typeface="Microsoft YaHei"/>
+                <a:cs typeface="Microsoft YaHei"/>
+              </a:rPr>
+              <a:t>队列等待 = 队头已等 + 前面各批剩余时间</a:t>
             </a:r>
           </a:p>
           <a:p>
@@ -7193,7 +7296,7 @@
                 <a:ea typeface="Microsoft YaHei"/>
                 <a:cs typeface="Microsoft YaHei"/>
               </a:rPr>
-              <a:t>误差 = TTFT 目标 - 预测 TTFT　　单条 KV 字节 = 2 × 层数 × KV 头数 × 头维 × token 数 × 每元素字节</a:t>
+              <a:t>单条 KV 字节 = 2 × 层数 × KV 头数 × 头维 × token 数 × 每元素字节</a:t>
             </a:r>
           </a:p>
         </p:txBody>
@@ -7207,8 +7310,8 @@
           <p:nvPr/>
         </p:nvGraphicFramePr>
         <p:xfrm>
-          <a:off x="256032" y="2048256"/>
-          <a:ext cx="11676888" cy="3838650"/>
+          <a:off x="256032" y="2395728"/>
+          <a:ext cx="11676888" cy="3511296"/>
         </p:xfrm>
         <a:graphic>
           <a:graphicData uri="http://schemas.openxmlformats.org/drawingml/2006/table">
@@ -7222,7 +7325,7 @@
                 <a:gridCol w="2240280"/>
                 <a:gridCol w="4224528"/>
               </a:tblGrid>
-              <a:tr h="365760">
+              <a:tr h="329184">
                 <a:tc>
                   <a:txBody>
                     <a:bodyPr wrap="square" lIns="73152" rIns="54864" tIns="18288" bIns="18288"/>
@@ -7404,7 +7507,7 @@
                   </a:tcPr>
                 </a:tc>
               </a:tr>
-              <a:tr h="578815">
+              <a:tr h="530352">
                 <a:tc>
                   <a:txBody>
                     <a:bodyPr wrap="square" lIns="73152" rIns="54864" tIns="18288" bIns="18288"/>
@@ -7586,7 +7689,7 @@
                   </a:tcPr>
                 </a:tc>
               </a:tr>
-              <a:tr h="578815">
+              <a:tr h="530352">
                 <a:tc>
                   <a:txBody>
                     <a:bodyPr wrap="square" lIns="73152" rIns="54864" tIns="18288" bIns="18288"/>
@@ -7768,7 +7871,7 @@
                   </a:tcPr>
                 </a:tc>
               </a:tr>
-              <a:tr h="578815">
+              <a:tr h="530352">
                 <a:tc>
                   <a:txBody>
                     <a:bodyPr wrap="square" lIns="73152" rIns="54864" tIns="18288" bIns="18288"/>
@@ -7950,7 +8053,7 @@
                   </a:tcPr>
                 </a:tc>
               </a:tr>
-              <a:tr h="578815">
+              <a:tr h="530352">
                 <a:tc>
                   <a:txBody>
                     <a:bodyPr wrap="square" lIns="73152" rIns="54864" tIns="18288" bIns="18288"/>
@@ -8132,7 +8235,7 @@
                   </a:tcPr>
                 </a:tc>
               </a:tr>
-              <a:tr h="578815">
+              <a:tr h="530352">
                 <a:tc>
                   <a:txBody>
                     <a:bodyPr wrap="square" lIns="73152" rIns="54864" tIns="18288" bIns="18288"/>
@@ -8314,7 +8417,7 @@
                   </a:tcPr>
                 </a:tc>
               </a:tr>
-              <a:tr h="578815">
+              <a:tr h="530352">
                 <a:tc>
                   <a:txBody>
                     <a:bodyPr wrap="square" lIns="73152" rIns="54864" tIns="18288" bIns="18288"/>

</xml_diff>